<commit_message>
Update presentation with full jurisdiction lists
</commit_message>
<xml_diff>
--- a/digital-id-presentation.pptx
+++ b/digital-id-presentation.pptx
@@ -7,6 +7,8 @@
   <p:sldIdLst>
     <p:sldId id="256" r:id="rId7"/>
     <p:sldId id="257" r:id="rId8"/>
+    <p:sldId id="258" r:id="rId9"/>
+    <p:sldId id="259" r:id="rId10"/>
   </p:sldIdLst>
   <p:sldSz cx="14630400" cy="8229600" type="screen4x3"/>
   <p:notesSz cx="6858000" cy="9144000"/>
@@ -3098,7 +3100,42 @@
         <p:spPr>
           <a:xfrm>
             <a:off x="457200" y="365760"/>
-            <a:ext cx="13716000" cy="914400"/>
+            <a:ext cx="13716000" cy="731520"/>
+          </a:xfrm>
+          <a:prstGeom prst="rect">
+            <a:avLst/>
+          </a:prstGeom>
+          <a:noFill/>
+        </p:spPr>
+        <p:txBody>
+          <a:bodyPr wrap="square">
+            <a:spAutoFit/>
+          </a:bodyPr>
+          <a:lstStyle/>
+          <a:p>
+            <a:pPr>
+              <a:defRPr sz="3600" b="1">
+                <a:solidFill>
+                  <a:srgbClr val="E8C547"/>
+                </a:solidFill>
+              </a:defRPr>
+            </a:pPr>
+            <a:r>
+              <a:t>How Many Digital IDs Per Citizen?</a:t>
+            </a:r>
+          </a:p>
+        </p:txBody>
+      </p:sp>
+      <p:sp>
+        <p:nvSpPr>
+          <p:cNvPr id="3" name="TextBox 2"/>
+          <p:cNvSpPr txBox="1"/>
+          <p:nvPr/>
+        </p:nvSpPr>
+        <p:spPr>
+          <a:xfrm>
+            <a:off x="457200" y="1005840"/>
+            <a:ext cx="13716000" cy="457200"/>
           </a:xfrm>
           <a:prstGeom prst="rect">
             <a:avLst/>
@@ -3112,28 +3149,28 @@
           <a:lstStyle/>
           <a:p>
             <a:pPr>
-              <a:defRPr sz="4400" b="1">
-                <a:solidFill>
-                  <a:srgbClr val="E8C547"/>
+              <a:defRPr sz="2200">
+                <a:solidFill>
+                  <a:srgbClr val="4ADE80"/>
                 </a:solidFill>
               </a:defRPr>
             </a:pPr>
             <a:r>
-              <a:t>How Many Digital IDs Per Citizen?</a:t>
-            </a:r>
-          </a:p>
-        </p:txBody>
-      </p:sp>
-      <p:sp>
-        <p:nvSpPr>
-          <p:cNvPr id="3" name="TextBox 2"/>
+              <a:t>Single Issuer Model - Government issues ONE digital credential per person (33 jurisdictions)</a:t>
+            </a:r>
+          </a:p>
+        </p:txBody>
+      </p:sp>
+      <p:sp>
+        <p:nvSpPr>
+          <p:cNvPr id="4" name="TextBox 3"/>
           <p:cNvSpPr txBox="1"/>
           <p:nvPr/>
         </p:nvSpPr>
         <p:spPr>
           <a:xfrm>
-            <a:off x="457200" y="1097280"/>
-            <a:ext cx="13716000" cy="548640"/>
+            <a:off x="457200" y="1645920"/>
+            <a:ext cx="2286000" cy="365760"/>
           </a:xfrm>
           <a:prstGeom prst="rect">
             <a:avLst/>
@@ -3147,60 +3184,15 @@
           <a:lstStyle/>
           <a:p>
             <a:pPr>
-              <a:defRPr sz="2800">
-                <a:solidFill>
-                  <a:srgbClr val="4ADE80"/>
+              <a:defRPr sz="1400" b="1">
+                <a:solidFill>
+                  <a:srgbClr val="E8C547"/>
                 </a:solidFill>
               </a:defRPr>
             </a:pPr>
             <a:r>
-              <a:t>Issuance Models by Jurisdiction Count</a:t>
-            </a:r>
-          </a:p>
-        </p:txBody>
-      </p:sp>
-      <p:sp>
-        <p:nvSpPr>
-          <p:cNvPr id="4" name="Rounded Rectangle 3"/>
-          <p:cNvSpPr/>
-          <p:nvPr/>
-        </p:nvSpPr>
-        <p:spPr>
-          <a:xfrm>
-            <a:off x="457200" y="2286000"/>
-            <a:ext cx="4114800" cy="2926080"/>
-          </a:xfrm>
-          <a:prstGeom prst="roundRect">
-            <a:avLst/>
-          </a:prstGeom>
-          <a:solidFill>
-            <a:srgbClr val="16213E"/>
-          </a:solidFill>
-          <a:ln>
-            <a:solidFill>
-              <a:srgbClr val="323250"/>
-            </a:solidFill>
-          </a:ln>
-        </p:spPr>
-        <p:style>
-          <a:lnRef idx="1">
-            <a:schemeClr val="accent1"/>
-          </a:lnRef>
-          <a:fillRef idx="3">
-            <a:schemeClr val="accent1"/>
-          </a:fillRef>
-          <a:effectRef idx="2">
-            <a:schemeClr val="accent1"/>
-          </a:effectRef>
-          <a:fontRef idx="minor">
-            <a:schemeClr val="lt1"/>
-          </a:fontRef>
-        </p:style>
-        <p:txBody>
-          <a:bodyPr rtlCol="0" anchor="ctr"/>
-          <a:lstStyle/>
-          <a:p>
-            <a:pPr algn="ctr"/>
+              <a:t>Americas:</a:t>
+            </a:r>
           </a:p>
         </p:txBody>
       </p:sp>
@@ -3212,8 +3204,8 @@
         </p:nvSpPr>
         <p:spPr>
           <a:xfrm>
-            <a:off x="731520" y="2560320"/>
-            <a:ext cx="3657600" cy="548640"/>
+            <a:off x="2743200" y="1645920"/>
+            <a:ext cx="11430000" cy="365760"/>
           </a:xfrm>
           <a:prstGeom prst="rect">
             <a:avLst/>
@@ -3227,14 +3219,14 @@
           <a:lstStyle/>
           <a:p>
             <a:pPr>
-              <a:defRPr sz="2400" b="1">
+              <a:defRPr sz="1300">
                 <a:solidFill>
                   <a:srgbClr val="FFFFFF"/>
                 </a:solidFill>
               </a:defRPr>
             </a:pPr>
             <a:r>
-              <a:t>Single Issuer</a:t>
+              <a:t>Brazil, Mexico, Argentina, Chile, Colombia, Peru</a:t>
             </a:r>
           </a:p>
         </p:txBody>
@@ -3247,8 +3239,8 @@
         </p:nvSpPr>
         <p:spPr>
           <a:xfrm>
-            <a:off x="731520" y="3200400"/>
-            <a:ext cx="3657600" cy="914400"/>
+            <a:off x="457200" y="2057400"/>
+            <a:ext cx="2286000" cy="365760"/>
           </a:xfrm>
           <a:prstGeom prst="rect">
             <a:avLst/>
@@ -3262,14 +3254,14 @@
           <a:lstStyle/>
           <a:p>
             <a:pPr>
-              <a:defRPr sz="5600" b="1">
+              <a:defRPr sz="1400" b="1">
                 <a:solidFill>
                   <a:srgbClr val="E8C547"/>
                 </a:solidFill>
               </a:defRPr>
             </a:pPr>
             <a:r>
-              <a:t>33</a:t>
+              <a:t>Europe:</a:t>
             </a:r>
           </a:p>
         </p:txBody>
@@ -3282,8 +3274,8 @@
         </p:nvSpPr>
         <p:spPr>
           <a:xfrm>
-            <a:off x="731520" y="4114800"/>
-            <a:ext cx="3657600" cy="548640"/>
+            <a:off x="2743200" y="2057400"/>
+            <a:ext cx="11430000" cy="365760"/>
           </a:xfrm>
           <a:prstGeom prst="rect">
             <a:avLst/>
@@ -3297,14 +3289,14 @@
           <a:lstStyle/>
           <a:p>
             <a:pPr>
-              <a:defRPr sz="1400">
-                <a:solidFill>
-                  <a:srgbClr val="969696"/>
+              <a:defRPr sz="1300">
+                <a:solidFill>
+                  <a:srgbClr val="FFFFFF"/>
                 </a:solidFill>
               </a:defRPr>
             </a:pPr>
             <a:r>
-              <a:t>Government issues ONE digital credential per person</a:t>
+              <a:t>Germany, Italy, Spain, France, Netherlands, Portugal, Austria, Belgium, Ireland, Poland, Czech Republic, Greece</a:t>
             </a:r>
           </a:p>
         </p:txBody>
@@ -3317,8 +3309,8 @@
         </p:nvSpPr>
         <p:spPr>
           <a:xfrm>
-            <a:off x="731520" y="4754880"/>
-            <a:ext cx="3657600" cy="365760"/>
+            <a:off x="457200" y="2468880"/>
+            <a:ext cx="2286000" cy="365760"/>
           </a:xfrm>
           <a:prstGeom prst="rect">
             <a:avLst/>
@@ -3332,73 +3324,28 @@
           <a:lstStyle/>
           <a:p>
             <a:pPr>
-              <a:defRPr sz="1200">
-                <a:solidFill>
-                  <a:srgbClr val="4ADE80"/>
+              <a:defRPr sz="1400" b="1">
+                <a:solidFill>
+                  <a:srgbClr val="E8C547"/>
                 </a:solidFill>
               </a:defRPr>
             </a:pPr>
             <a:r>
-              <a:t>India, Brazil, Germany, US states</a:t>
-            </a:r>
-          </a:p>
-        </p:txBody>
-      </p:sp>
-      <p:sp>
-        <p:nvSpPr>
-          <p:cNvPr id="9" name="Rounded Rectangle 8"/>
-          <p:cNvSpPr/>
-          <p:nvPr/>
-        </p:nvSpPr>
-        <p:spPr>
-          <a:xfrm>
-            <a:off x="4846320" y="2286000"/>
-            <a:ext cx="4114800" cy="2926080"/>
-          </a:xfrm>
-          <a:prstGeom prst="roundRect">
-            <a:avLst/>
-          </a:prstGeom>
-          <a:solidFill>
-            <a:srgbClr val="16213E"/>
-          </a:solidFill>
-          <a:ln>
-            <a:solidFill>
-              <a:srgbClr val="323250"/>
-            </a:solidFill>
-          </a:ln>
-        </p:spPr>
-        <p:style>
-          <a:lnRef idx="1">
-            <a:schemeClr val="accent1"/>
-          </a:lnRef>
-          <a:fillRef idx="3">
-            <a:schemeClr val="accent1"/>
-          </a:fillRef>
-          <a:effectRef idx="2">
-            <a:schemeClr val="accent1"/>
-          </a:effectRef>
-          <a:fontRef idx="minor">
-            <a:schemeClr val="lt1"/>
-          </a:fontRef>
-        </p:style>
-        <p:txBody>
-          <a:bodyPr rtlCol="0" anchor="ctr"/>
-          <a:lstStyle/>
-          <a:p>
-            <a:pPr algn="ctr"/>
-          </a:p>
-        </p:txBody>
-      </p:sp>
-      <p:sp>
-        <p:nvSpPr>
-          <p:cNvPr id="10" name="TextBox 9"/>
+              <a:t>Asia-Pacific:</a:t>
+            </a:r>
+          </a:p>
+        </p:txBody>
+      </p:sp>
+      <p:sp>
+        <p:nvSpPr>
+          <p:cNvPr id="9" name="TextBox 8"/>
           <p:cNvSpPr txBox="1"/>
           <p:nvPr/>
         </p:nvSpPr>
         <p:spPr>
           <a:xfrm>
-            <a:off x="5120640" y="2560320"/>
-            <a:ext cx="3657600" cy="548640"/>
+            <a:off x="2743200" y="2468880"/>
+            <a:ext cx="11430000" cy="365760"/>
           </a:xfrm>
           <a:prstGeom prst="rect">
             <a:avLst/>
@@ -3412,28 +3359,28 @@
           <a:lstStyle/>
           <a:p>
             <a:pPr>
-              <a:defRPr sz="2400" b="1">
+              <a:defRPr sz="1300">
                 <a:solidFill>
                   <a:srgbClr val="FFFFFF"/>
                 </a:solidFill>
               </a:defRPr>
             </a:pPr>
             <a:r>
-              <a:t>Cloud-Based</a:t>
-            </a:r>
-          </a:p>
-        </p:txBody>
-      </p:sp>
-      <p:sp>
-        <p:nvSpPr>
-          <p:cNvPr id="11" name="TextBox 10"/>
+              <a:t>India, South Korea, Taiwan, Malaysia, Thailand</a:t>
+            </a:r>
+          </a:p>
+        </p:txBody>
+      </p:sp>
+      <p:sp>
+        <p:nvSpPr>
+          <p:cNvPr id="10" name="TextBox 9"/>
           <p:cNvSpPr txBox="1"/>
           <p:nvPr/>
         </p:nvSpPr>
         <p:spPr>
           <a:xfrm>
-            <a:off x="5120640" y="3200400"/>
-            <a:ext cx="3657600" cy="914400"/>
+            <a:off x="457200" y="2880360"/>
+            <a:ext cx="2286000" cy="365760"/>
           </a:xfrm>
           <a:prstGeom prst="rect">
             <a:avLst/>
@@ -3447,28 +3394,28 @@
           <a:lstStyle/>
           <a:p>
             <a:pPr>
-              <a:defRPr sz="5600" b="1">
+              <a:defRPr sz="1400" b="1">
                 <a:solidFill>
                   <a:srgbClr val="E8C547"/>
                 </a:solidFill>
               </a:defRPr>
             </a:pPr>
             <a:r>
-              <a:t>14</a:t>
-            </a:r>
-          </a:p>
-        </p:txBody>
-      </p:sp>
-      <p:sp>
-        <p:nvSpPr>
-          <p:cNvPr id="12" name="TextBox 11"/>
+              <a:t>Middle East:</a:t>
+            </a:r>
+          </a:p>
+        </p:txBody>
+      </p:sp>
+      <p:sp>
+        <p:nvSpPr>
+          <p:cNvPr id="11" name="TextBox 10"/>
           <p:cNvSpPr txBox="1"/>
           <p:nvPr/>
         </p:nvSpPr>
         <p:spPr>
           <a:xfrm>
-            <a:off x="5120640" y="4114800"/>
-            <a:ext cx="3657600" cy="548640"/>
+            <a:off x="2743200" y="2880360"/>
+            <a:ext cx="11430000" cy="365760"/>
           </a:xfrm>
           <a:prstGeom prst="rect">
             <a:avLst/>
@@ -3482,28 +3429,28 @@
           <a:lstStyle/>
           <a:p>
             <a:pPr>
-              <a:defRPr sz="1400">
-                <a:solidFill>
-                  <a:srgbClr val="969696"/>
+              <a:defRPr sz="1300">
+                <a:solidFill>
+                  <a:srgbClr val="FFFFFF"/>
                 </a:solidFill>
               </a:defRPr>
             </a:pPr>
             <a:r>
-              <a:t>Browser/app account, no physical credential issued</a:t>
-            </a:r>
-          </a:p>
-        </p:txBody>
-      </p:sp>
-      <p:sp>
-        <p:nvSpPr>
-          <p:cNvPr id="13" name="TextBox 12"/>
+              <a:t>Israel, UAE, Saudi Arabia, Qatar, Oman</a:t>
+            </a:r>
+          </a:p>
+        </p:txBody>
+      </p:sp>
+      <p:sp>
+        <p:nvSpPr>
+          <p:cNvPr id="12" name="TextBox 11"/>
           <p:cNvSpPr txBox="1"/>
           <p:nvPr/>
         </p:nvSpPr>
         <p:spPr>
           <a:xfrm>
-            <a:off x="5120640" y="4754880"/>
-            <a:ext cx="3657600" cy="365760"/>
+            <a:off x="457200" y="3291840"/>
+            <a:ext cx="2286000" cy="365760"/>
           </a:xfrm>
           <a:prstGeom prst="rect">
             <a:avLst/>
@@ -3517,73 +3464,28 @@
           <a:lstStyle/>
           <a:p>
             <a:pPr>
-              <a:defRPr sz="1200">
-                <a:solidFill>
-                  <a:srgbClr val="4ADE80"/>
+              <a:defRPr sz="1400" b="1">
+                <a:solidFill>
+                  <a:srgbClr val="E8C547"/>
                 </a:solidFill>
               </a:defRPr>
             </a:pPr>
             <a:r>
-              <a:t>Australia, Singapore, Kenya</a:t>
-            </a:r>
-          </a:p>
-        </p:txBody>
-      </p:sp>
-      <p:sp>
-        <p:nvSpPr>
-          <p:cNvPr id="14" name="Rounded Rectangle 13"/>
-          <p:cNvSpPr/>
-          <p:nvPr/>
-        </p:nvSpPr>
-        <p:spPr>
-          <a:xfrm>
-            <a:off x="9235440" y="2286000"/>
-            <a:ext cx="4114800" cy="2926080"/>
-          </a:xfrm>
-          <a:prstGeom prst="roundRect">
-            <a:avLst/>
-          </a:prstGeom>
-          <a:solidFill>
-            <a:srgbClr val="16213E"/>
-          </a:solidFill>
-          <a:ln>
-            <a:solidFill>
-              <a:srgbClr val="323250"/>
-            </a:solidFill>
-          </a:ln>
-        </p:spPr>
-        <p:style>
-          <a:lnRef idx="1">
-            <a:schemeClr val="accent1"/>
-          </a:lnRef>
-          <a:fillRef idx="3">
-            <a:schemeClr val="accent1"/>
-          </a:fillRef>
-          <a:effectRef idx="2">
-            <a:schemeClr val="accent1"/>
-          </a:effectRef>
-          <a:fontRef idx="minor">
-            <a:schemeClr val="lt1"/>
-          </a:fontRef>
-        </p:style>
-        <p:txBody>
-          <a:bodyPr rtlCol="0" anchor="ctr"/>
-          <a:lstStyle/>
-          <a:p>
-            <a:pPr algn="ctr"/>
-          </a:p>
-        </p:txBody>
-      </p:sp>
-      <p:sp>
-        <p:nvSpPr>
-          <p:cNvPr id="15" name="TextBox 14"/>
+              <a:t>Africa:</a:t>
+            </a:r>
+          </a:p>
+        </p:txBody>
+      </p:sp>
+      <p:sp>
+        <p:nvSpPr>
+          <p:cNvPr id="13" name="TextBox 12"/>
           <p:cNvSpPr txBox="1"/>
           <p:nvPr/>
         </p:nvSpPr>
         <p:spPr>
           <a:xfrm>
-            <a:off x="9509760" y="2560320"/>
-            <a:ext cx="3657600" cy="548640"/>
+            <a:off x="2743200" y="3291840"/>
+            <a:ext cx="11430000" cy="365760"/>
           </a:xfrm>
           <a:prstGeom prst="rect">
             <a:avLst/>
@@ -3597,28 +3499,28 @@
           <a:lstStyle/>
           <a:p>
             <a:pPr>
-              <a:defRPr sz="2400" b="1">
+              <a:defRPr sz="1300">
                 <a:solidFill>
                   <a:srgbClr val="FFFFFF"/>
                 </a:solidFill>
               </a:defRPr>
             </a:pPr>
             <a:r>
-              <a:t>Multiple Providers</a:t>
-            </a:r>
-          </a:p>
-        </p:txBody>
-      </p:sp>
-      <p:sp>
-        <p:nvSpPr>
-          <p:cNvPr id="16" name="TextBox 15"/>
+              <a:t>Nigeria, Kenya</a:t>
+            </a:r>
+          </a:p>
+        </p:txBody>
+      </p:sp>
+      <p:sp>
+        <p:nvSpPr>
+          <p:cNvPr id="14" name="TextBox 13"/>
           <p:cNvSpPr txBox="1"/>
           <p:nvPr/>
         </p:nvSpPr>
         <p:spPr>
           <a:xfrm>
-            <a:off x="9509760" y="3200400"/>
-            <a:ext cx="3657600" cy="914400"/>
+            <a:off x="457200" y="3703320"/>
+            <a:ext cx="2286000" cy="365760"/>
           </a:xfrm>
           <a:prstGeom prst="rect">
             <a:avLst/>
@@ -3632,28 +3534,28 @@
           <a:lstStyle/>
           <a:p>
             <a:pPr>
-              <a:defRPr sz="5600" b="1">
+              <a:defRPr sz="1400" b="1">
                 <a:solidFill>
                   <a:srgbClr val="E8C547"/>
                 </a:solidFill>
               </a:defRPr>
             </a:pPr>
             <a:r>
-              <a:t>3</a:t>
-            </a:r>
-          </a:p>
-        </p:txBody>
-      </p:sp>
-      <p:sp>
-        <p:nvSpPr>
-          <p:cNvPr id="17" name="TextBox 16"/>
+              <a:t>North America:</a:t>
+            </a:r>
+          </a:p>
+        </p:txBody>
+      </p:sp>
+      <p:sp>
+        <p:nvSpPr>
+          <p:cNvPr id="15" name="TextBox 14"/>
           <p:cNvSpPr txBox="1"/>
           <p:nvPr/>
         </p:nvSpPr>
         <p:spPr>
           <a:xfrm>
-            <a:off x="9509760" y="4114800"/>
-            <a:ext cx="3657600" cy="548640"/>
+            <a:off x="2743200" y="3703320"/>
+            <a:ext cx="11430000" cy="365760"/>
           </a:xfrm>
           <a:prstGeom prst="rect">
             <a:avLst/>
@@ -3667,103 +3569,14 @@
           <a:lstStyle/>
           <a:p>
             <a:pPr>
-              <a:defRPr sz="1400">
-                <a:solidFill>
-                  <a:srgbClr val="969696"/>
+              <a:defRPr sz="1300">
+                <a:solidFill>
+                  <a:srgbClr val="FFFFFF"/>
                 </a:solidFill>
               </a:defRPr>
             </a:pPr>
             <a:r>
-              <a:t>Multiple issuers (banks, telcos) provide credentials</a:t>
-            </a:r>
-          </a:p>
-        </p:txBody>
-      </p:sp>
-      <p:sp>
-        <p:nvSpPr>
-          <p:cNvPr id="18" name="TextBox 17"/>
-          <p:cNvSpPr txBox="1"/>
-          <p:nvPr/>
-        </p:nvSpPr>
-        <p:spPr>
-          <a:xfrm>
-            <a:off x="9509760" y="4754880"/>
-            <a:ext cx="3657600" cy="365760"/>
-          </a:xfrm>
-          <a:prstGeom prst="rect">
-            <a:avLst/>
-          </a:prstGeom>
-          <a:noFill/>
-        </p:spPr>
-        <p:txBody>
-          <a:bodyPr wrap="none">
-            <a:spAutoFit/>
-          </a:bodyPr>
-          <a:lstStyle/>
-          <a:p>
-            <a:pPr>
-              <a:defRPr sz="1200">
-                <a:solidFill>
-                  <a:srgbClr val="4ADE80"/>
-                </a:solidFill>
-              </a:defRPr>
-            </a:pPr>
-            <a:r>
-              <a:t>Estonia, Sweden, Finland</a:t>
-            </a:r>
-          </a:p>
-        </p:txBody>
-      </p:sp>
-      <p:sp>
-        <p:nvSpPr>
-          <p:cNvPr id="19" name="Rounded Rectangle 18"/>
-          <p:cNvSpPr/>
-          <p:nvPr/>
-        </p:nvSpPr>
-        <p:spPr>
-          <a:xfrm>
-            <a:off x="457200" y="5669280"/>
-            <a:ext cx="13716000" cy="1097280"/>
-          </a:xfrm>
-          <a:prstGeom prst="roundRect">
-            <a:avLst/>
-          </a:prstGeom>
-          <a:solidFill>
-            <a:srgbClr val="16213E"/>
-          </a:solidFill>
-          <a:ln>
-            <a:solidFill>
-              <a:srgbClr val="E8C547"/>
-            </a:solidFill>
-          </a:ln>
-        </p:spPr>
-        <p:style>
-          <a:lnRef idx="1">
-            <a:schemeClr val="accent1"/>
-          </a:lnRef>
-          <a:fillRef idx="3">
-            <a:schemeClr val="accent1"/>
-          </a:fillRef>
-          <a:effectRef idx="2">
-            <a:schemeClr val="accent1"/>
-          </a:effectRef>
-          <a:fontRef idx="minor">
-            <a:schemeClr val="lt1"/>
-          </a:fontRef>
-        </p:style>
-        <p:txBody>
-          <a:bodyPr rtlCol="0" anchor="ctr"/>
-          <a:lstStyle/>
-          <a:p>
-            <a:pPr algn="ctr">
-              <a:defRPr sz="1800">
-                <a:solidFill>
-                  <a:srgbClr val="FFFFFF"/>
-                </a:solidFill>
-              </a:defRPr>
-            </a:pPr>
-            <a:r>
-              <a:t>Key Insight: Most jurisdictions (67%) use a single issuer model where the government provides one digital identity per citizen.</a:t>
+              <a:t>US (14 states), Canada provinces</a:t>
             </a:r>
           </a:p>
         </p:txBody>
@@ -3795,7 +3608,42 @@
         <p:spPr>
           <a:xfrm>
             <a:off x="457200" y="365760"/>
-            <a:ext cx="13716000" cy="914400"/>
+            <a:ext cx="13716000" cy="731520"/>
+          </a:xfrm>
+          <a:prstGeom prst="rect">
+            <a:avLst/>
+          </a:prstGeom>
+          <a:noFill/>
+        </p:spPr>
+        <p:txBody>
+          <a:bodyPr wrap="square">
+            <a:spAutoFit/>
+          </a:bodyPr>
+          <a:lstStyle/>
+          <a:p>
+            <a:pPr>
+              <a:defRPr sz="3600" b="1">
+                <a:solidFill>
+                  <a:srgbClr val="E8C547"/>
+                </a:solidFill>
+              </a:defRPr>
+            </a:pPr>
+            <a:r>
+              <a:t>How Many Digital IDs Per Citizen?</a:t>
+            </a:r>
+          </a:p>
+        </p:txBody>
+      </p:sp>
+      <p:sp>
+        <p:nvSpPr>
+          <p:cNvPr id="3" name="TextBox 2"/>
+          <p:cNvSpPr txBox="1"/>
+          <p:nvPr/>
+        </p:nvSpPr>
+        <p:spPr>
+          <a:xfrm>
+            <a:off x="457200" y="1005840"/>
+            <a:ext cx="13716000" cy="457200"/>
           </a:xfrm>
           <a:prstGeom prst="rect">
             <a:avLst/>
@@ -3809,28 +3657,28 @@
           <a:lstStyle/>
           <a:p>
             <a:pPr>
-              <a:defRPr sz="4400" b="1">
-                <a:solidFill>
-                  <a:srgbClr val="E8C547"/>
+              <a:defRPr sz="2200">
+                <a:solidFill>
+                  <a:srgbClr val="4ADE80"/>
                 </a:solidFill>
               </a:defRPr>
             </a:pPr>
             <a:r>
-              <a:t>Technology Approaches</a:t>
-            </a:r>
-          </a:p>
-        </p:txBody>
-      </p:sp>
-      <p:sp>
-        <p:nvSpPr>
-          <p:cNvPr id="3" name="TextBox 2"/>
+              <a:t>Cloud-Based Model - Browser/app account, no physical credential issued (14 jurisdictions)</a:t>
+            </a:r>
+          </a:p>
+        </p:txBody>
+      </p:sp>
+      <p:sp>
+        <p:nvSpPr>
+          <p:cNvPr id="4" name="TextBox 3"/>
           <p:cNvSpPr txBox="1"/>
           <p:nvPr/>
         </p:nvSpPr>
         <p:spPr>
           <a:xfrm>
-            <a:off x="457200" y="1097280"/>
-            <a:ext cx="13716000" cy="548640"/>
+            <a:off x="457200" y="1645920"/>
+            <a:ext cx="2286000" cy="365760"/>
           </a:xfrm>
           <a:prstGeom prst="rect">
             <a:avLst/>
@@ -3844,28 +3692,28 @@
           <a:lstStyle/>
           <a:p>
             <a:pPr>
-              <a:defRPr sz="2800">
-                <a:solidFill>
-                  <a:srgbClr val="4ADE80"/>
+              <a:defRPr sz="1400" b="1">
+                <a:solidFill>
+                  <a:srgbClr val="60A5FA"/>
                 </a:solidFill>
               </a:defRPr>
             </a:pPr>
             <a:r>
-              <a:t>Underlying Credential Formats &amp; Protocols</a:t>
-            </a:r>
-          </a:p>
-        </p:txBody>
-      </p:sp>
-      <p:sp>
-        <p:nvSpPr>
-          <p:cNvPr id="4" name="TextBox 3"/>
+              <a:t>Asia-Pacific:</a:t>
+            </a:r>
+          </a:p>
+        </p:txBody>
+      </p:sp>
+      <p:sp>
+        <p:nvSpPr>
+          <p:cNvPr id="5" name="TextBox 4"/>
           <p:cNvSpPr txBox="1"/>
           <p:nvPr/>
         </p:nvSpPr>
         <p:spPr>
           <a:xfrm>
-            <a:off x="457200" y="2011680"/>
-            <a:ext cx="2743200" cy="457200"/>
+            <a:off x="2743200" y="1645920"/>
+            <a:ext cx="11430000" cy="365760"/>
           </a:xfrm>
           <a:prstGeom prst="rect">
             <a:avLst/>
@@ -3879,34 +3727,542 @@
           <a:lstStyle/>
           <a:p>
             <a:pPr>
-              <a:defRPr sz="1600">
+              <a:defRPr sz="1300">
                 <a:solidFill>
                   <a:srgbClr val="FFFFFF"/>
                 </a:solidFill>
               </a:defRPr>
             </a:pPr>
             <a:r>
-              <a:t>ISO mDL (mobile DL)</a:t>
-            </a:r>
-          </a:p>
-        </p:txBody>
-      </p:sp>
-      <p:sp>
-        <p:nvSpPr>
-          <p:cNvPr id="5" name="Rounded Rectangle 4"/>
+              <a:t>Australia (myID), Singapore (SingPass), China (Cyber ID), Hong Kong, New Zealand</a:t>
+            </a:r>
+          </a:p>
+        </p:txBody>
+      </p:sp>
+      <p:sp>
+        <p:nvSpPr>
+          <p:cNvPr id="6" name="TextBox 5"/>
+          <p:cNvSpPr txBox="1"/>
+          <p:nvPr/>
+        </p:nvSpPr>
+        <p:spPr>
+          <a:xfrm>
+            <a:off x="457200" y="2057400"/>
+            <a:ext cx="2286000" cy="365760"/>
+          </a:xfrm>
+          <a:prstGeom prst="rect">
+            <a:avLst/>
+          </a:prstGeom>
+          <a:noFill/>
+        </p:spPr>
+        <p:txBody>
+          <a:bodyPr wrap="none">
+            <a:spAutoFit/>
+          </a:bodyPr>
+          <a:lstStyle/>
+          <a:p>
+            <a:pPr>
+              <a:defRPr sz="1400" b="1">
+                <a:solidFill>
+                  <a:srgbClr val="60A5FA"/>
+                </a:solidFill>
+              </a:defRPr>
+            </a:pPr>
+            <a:r>
+              <a:t>Europe:</a:t>
+            </a:r>
+          </a:p>
+        </p:txBody>
+      </p:sp>
+      <p:sp>
+        <p:nvSpPr>
+          <p:cNvPr id="7" name="TextBox 6"/>
+          <p:cNvSpPr txBox="1"/>
+          <p:nvPr/>
+        </p:nvSpPr>
+        <p:spPr>
+          <a:xfrm>
+            <a:off x="2743200" y="2057400"/>
+            <a:ext cx="11430000" cy="365760"/>
+          </a:xfrm>
+          <a:prstGeom prst="rect">
+            <a:avLst/>
+          </a:prstGeom>
+          <a:noFill/>
+        </p:spPr>
+        <p:txBody>
+          <a:bodyPr wrap="none">
+            <a:spAutoFit/>
+          </a:bodyPr>
+          <a:lstStyle/>
+          <a:p>
+            <a:pPr>
+              <a:defRPr sz="1300">
+                <a:solidFill>
+                  <a:srgbClr val="FFFFFF"/>
+                </a:solidFill>
+              </a:defRPr>
+            </a:pPr>
+            <a:r>
+              <a:t>UK (GOV.UK), Norway, Denmark</a:t>
+            </a:r>
+          </a:p>
+        </p:txBody>
+      </p:sp>
+      <p:sp>
+        <p:nvSpPr>
+          <p:cNvPr id="8" name="TextBox 7"/>
+          <p:cNvSpPr txBox="1"/>
+          <p:nvPr/>
+        </p:nvSpPr>
+        <p:spPr>
+          <a:xfrm>
+            <a:off x="457200" y="2468880"/>
+            <a:ext cx="2286000" cy="365760"/>
+          </a:xfrm>
+          <a:prstGeom prst="rect">
+            <a:avLst/>
+          </a:prstGeom>
+          <a:noFill/>
+        </p:spPr>
+        <p:txBody>
+          <a:bodyPr wrap="none">
+            <a:spAutoFit/>
+          </a:bodyPr>
+          <a:lstStyle/>
+          <a:p>
+            <a:pPr>
+              <a:defRPr sz="1400" b="1">
+                <a:solidFill>
+                  <a:srgbClr val="60A5FA"/>
+                </a:solidFill>
+              </a:defRPr>
+            </a:pPr>
+            <a:r>
+              <a:t>Americas:</a:t>
+            </a:r>
+          </a:p>
+        </p:txBody>
+      </p:sp>
+      <p:sp>
+        <p:nvSpPr>
+          <p:cNvPr id="9" name="TextBox 8"/>
+          <p:cNvSpPr txBox="1"/>
+          <p:nvPr/>
+        </p:nvSpPr>
+        <p:spPr>
+          <a:xfrm>
+            <a:off x="2743200" y="2468880"/>
+            <a:ext cx="11430000" cy="365760"/>
+          </a:xfrm>
+          <a:prstGeom prst="rect">
+            <a:avLst/>
+          </a:prstGeom>
+          <a:noFill/>
+        </p:spPr>
+        <p:txBody>
+          <a:bodyPr wrap="none">
+            <a:spAutoFit/>
+          </a:bodyPr>
+          <a:lstStyle/>
+          <a:p>
+            <a:pPr>
+              <a:defRPr sz="1300">
+                <a:solidFill>
+                  <a:srgbClr val="FFFFFF"/>
+                </a:solidFill>
+              </a:defRPr>
+            </a:pPr>
+            <a:r>
+              <a:t>Brazil (Gov.br)</a:t>
+            </a:r>
+          </a:p>
+        </p:txBody>
+      </p:sp>
+      <p:sp>
+        <p:nvSpPr>
+          <p:cNvPr id="10" name="TextBox 9"/>
+          <p:cNvSpPr txBox="1"/>
+          <p:nvPr/>
+        </p:nvSpPr>
+        <p:spPr>
+          <a:xfrm>
+            <a:off x="457200" y="2880360"/>
+            <a:ext cx="2286000" cy="365760"/>
+          </a:xfrm>
+          <a:prstGeom prst="rect">
+            <a:avLst/>
+          </a:prstGeom>
+          <a:noFill/>
+        </p:spPr>
+        <p:txBody>
+          <a:bodyPr wrap="none">
+            <a:spAutoFit/>
+          </a:bodyPr>
+          <a:lstStyle/>
+          <a:p>
+            <a:pPr>
+              <a:defRPr sz="1400" b="1">
+                <a:solidFill>
+                  <a:srgbClr val="60A5FA"/>
+                </a:solidFill>
+              </a:defRPr>
+            </a:pPr>
+            <a:r>
+              <a:t>Africa:</a:t>
+            </a:r>
+          </a:p>
+        </p:txBody>
+      </p:sp>
+      <p:sp>
+        <p:nvSpPr>
+          <p:cNvPr id="11" name="TextBox 10"/>
+          <p:cNvSpPr txBox="1"/>
+          <p:nvPr/>
+        </p:nvSpPr>
+        <p:spPr>
+          <a:xfrm>
+            <a:off x="2743200" y="2880360"/>
+            <a:ext cx="11430000" cy="365760"/>
+          </a:xfrm>
+          <a:prstGeom prst="rect">
+            <a:avLst/>
+          </a:prstGeom>
+          <a:noFill/>
+        </p:spPr>
+        <p:txBody>
+          <a:bodyPr wrap="none">
+            <a:spAutoFit/>
+          </a:bodyPr>
+          <a:lstStyle/>
+          <a:p>
+            <a:pPr>
+              <a:defRPr sz="1300">
+                <a:solidFill>
+                  <a:srgbClr val="FFFFFF"/>
+                </a:solidFill>
+              </a:defRPr>
+            </a:pPr>
+            <a:r>
+              <a:t>Kenya (eCitizen), Ghana, South Africa</a:t>
+            </a:r>
+          </a:p>
+        </p:txBody>
+      </p:sp>
+    </p:spTree>
+  </p:cSld>
+  <p:clrMapOvr>
+    <a:masterClrMapping/>
+  </p:clrMapOvr>
+</p:sld>
+</file>
+
+<file path=ppt/slides/slide3.xml><?xml version="1.0" encoding="utf-8"?>
+<p:sld xmlns:a="http://schemas.openxmlformats.org/drawingml/2006/main" xmlns:p="http://schemas.openxmlformats.org/presentationml/2006/main" xmlns:r="http://schemas.openxmlformats.org/officeDocument/2006/relationships">
+  <p:cSld>
+    <p:spTree>
+      <p:nvGrpSpPr>
+        <p:cNvPr id="1" name=""/>
+        <p:cNvGrpSpPr/>
+        <p:nvPr/>
+      </p:nvGrpSpPr>
+      <p:grpSpPr/>
+      <p:sp>
+        <p:nvSpPr>
+          <p:cNvPr id="2" name="TextBox 1"/>
+          <p:cNvSpPr txBox="1"/>
+          <p:nvPr/>
+        </p:nvSpPr>
+        <p:spPr>
+          <a:xfrm>
+            <a:off x="457200" y="365760"/>
+            <a:ext cx="13716000" cy="731520"/>
+          </a:xfrm>
+          <a:prstGeom prst="rect">
+            <a:avLst/>
+          </a:prstGeom>
+          <a:noFill/>
+        </p:spPr>
+        <p:txBody>
+          <a:bodyPr wrap="square">
+            <a:spAutoFit/>
+          </a:bodyPr>
+          <a:lstStyle/>
+          <a:p>
+            <a:pPr>
+              <a:defRPr sz="3600" b="1">
+                <a:solidFill>
+                  <a:srgbClr val="E8C547"/>
+                </a:solidFill>
+              </a:defRPr>
+            </a:pPr>
+            <a:r>
+              <a:t>How Many Digital IDs Per Citizen?</a:t>
+            </a:r>
+          </a:p>
+        </p:txBody>
+      </p:sp>
+      <p:sp>
+        <p:nvSpPr>
+          <p:cNvPr id="3" name="TextBox 2"/>
+          <p:cNvSpPr txBox="1"/>
+          <p:nvPr/>
+        </p:nvSpPr>
+        <p:spPr>
+          <a:xfrm>
+            <a:off x="457200" y="1005840"/>
+            <a:ext cx="13716000" cy="457200"/>
+          </a:xfrm>
+          <a:prstGeom prst="rect">
+            <a:avLst/>
+          </a:prstGeom>
+          <a:noFill/>
+        </p:spPr>
+        <p:txBody>
+          <a:bodyPr wrap="none">
+            <a:spAutoFit/>
+          </a:bodyPr>
+          <a:lstStyle/>
+          <a:p>
+            <a:pPr>
+              <a:defRPr sz="2200">
+                <a:solidFill>
+                  <a:srgbClr val="4ADE80"/>
+                </a:solidFill>
+              </a:defRPr>
+            </a:pPr>
+            <a:r>
+              <a:t>Multiple Providers Model - Banks/telcos issue credentials (3 jurisdictions)</a:t>
+            </a:r>
+          </a:p>
+        </p:txBody>
+      </p:sp>
+      <p:sp>
+        <p:nvSpPr>
+          <p:cNvPr id="4" name="TextBox 3"/>
+          <p:cNvSpPr txBox="1"/>
+          <p:nvPr/>
+        </p:nvSpPr>
+        <p:spPr>
+          <a:xfrm>
+            <a:off x="457200" y="1645920"/>
+            <a:ext cx="2743200" cy="365760"/>
+          </a:xfrm>
+          <a:prstGeom prst="rect">
+            <a:avLst/>
+          </a:prstGeom>
+          <a:noFill/>
+        </p:spPr>
+        <p:txBody>
+          <a:bodyPr wrap="none">
+            <a:spAutoFit/>
+          </a:bodyPr>
+          <a:lstStyle/>
+          <a:p>
+            <a:pPr>
+              <a:defRPr sz="1400" b="1">
+                <a:solidFill>
+                  <a:srgbClr val="4ADE80"/>
+                </a:solidFill>
+              </a:defRPr>
+            </a:pPr>
+            <a:r>
+              <a:t>Estonia:</a:t>
+            </a:r>
+          </a:p>
+        </p:txBody>
+      </p:sp>
+      <p:sp>
+        <p:nvSpPr>
+          <p:cNvPr id="5" name="TextBox 4"/>
+          <p:cNvSpPr txBox="1"/>
+          <p:nvPr/>
+        </p:nvSpPr>
+        <p:spPr>
+          <a:xfrm>
+            <a:off x="2743200" y="1645920"/>
+            <a:ext cx="10972800" cy="365760"/>
+          </a:xfrm>
+          <a:prstGeom prst="rect">
+            <a:avLst/>
+          </a:prstGeom>
+          <a:noFill/>
+        </p:spPr>
+        <p:txBody>
+          <a:bodyPr wrap="none">
+            <a:spAutoFit/>
+          </a:bodyPr>
+          <a:lstStyle/>
+          <a:p>
+            <a:pPr>
+              <a:defRPr sz="1300">
+                <a:solidFill>
+                  <a:srgbClr val="FFFFFF"/>
+                </a:solidFill>
+              </a:defRPr>
+            </a:pPr>
+            <a:r>
+              <a:t>ID card + Mobile-ID + Smart-ID (multiple credentials per person)</a:t>
+            </a:r>
+          </a:p>
+        </p:txBody>
+      </p:sp>
+      <p:sp>
+        <p:nvSpPr>
+          <p:cNvPr id="6" name="TextBox 5"/>
+          <p:cNvSpPr txBox="1"/>
+          <p:nvPr/>
+        </p:nvSpPr>
+        <p:spPr>
+          <a:xfrm>
+            <a:off x="457200" y="2103120"/>
+            <a:ext cx="2743200" cy="365760"/>
+          </a:xfrm>
+          <a:prstGeom prst="rect">
+            <a:avLst/>
+          </a:prstGeom>
+          <a:noFill/>
+        </p:spPr>
+        <p:txBody>
+          <a:bodyPr wrap="none">
+            <a:spAutoFit/>
+          </a:bodyPr>
+          <a:lstStyle/>
+          <a:p>
+            <a:pPr>
+              <a:defRPr sz="1400" b="1">
+                <a:solidFill>
+                  <a:srgbClr val="4ADE80"/>
+                </a:solidFill>
+              </a:defRPr>
+            </a:pPr>
+            <a:r>
+              <a:t>Sweden:</a:t>
+            </a:r>
+          </a:p>
+        </p:txBody>
+      </p:sp>
+      <p:sp>
+        <p:nvSpPr>
+          <p:cNvPr id="7" name="TextBox 6"/>
+          <p:cNvSpPr txBox="1"/>
+          <p:nvPr/>
+        </p:nvSpPr>
+        <p:spPr>
+          <a:xfrm>
+            <a:off x="2743200" y="2103120"/>
+            <a:ext cx="10972800" cy="365760"/>
+          </a:xfrm>
+          <a:prstGeom prst="rect">
+            <a:avLst/>
+          </a:prstGeom>
+          <a:noFill/>
+        </p:spPr>
+        <p:txBody>
+          <a:bodyPr wrap="none">
+            <a:spAutoFit/>
+          </a:bodyPr>
+          <a:lstStyle/>
+          <a:p>
+            <a:pPr>
+              <a:defRPr sz="1300">
+                <a:solidFill>
+                  <a:srgbClr val="FFFFFF"/>
+                </a:solidFill>
+              </a:defRPr>
+            </a:pPr>
+            <a:r>
+              <a:t>BankID from multiple banks (common to have 3-4 BankIDs)</a:t>
+            </a:r>
+          </a:p>
+        </p:txBody>
+      </p:sp>
+      <p:sp>
+        <p:nvSpPr>
+          <p:cNvPr id="8" name="TextBox 7"/>
+          <p:cNvSpPr txBox="1"/>
+          <p:nvPr/>
+        </p:nvSpPr>
+        <p:spPr>
+          <a:xfrm>
+            <a:off x="457200" y="2560320"/>
+            <a:ext cx="2743200" cy="365760"/>
+          </a:xfrm>
+          <a:prstGeom prst="rect">
+            <a:avLst/>
+          </a:prstGeom>
+          <a:noFill/>
+        </p:spPr>
+        <p:txBody>
+          <a:bodyPr wrap="none">
+            <a:spAutoFit/>
+          </a:bodyPr>
+          <a:lstStyle/>
+          <a:p>
+            <a:pPr>
+              <a:defRPr sz="1400" b="1">
+                <a:solidFill>
+                  <a:srgbClr val="4ADE80"/>
+                </a:solidFill>
+              </a:defRPr>
+            </a:pPr>
+            <a:r>
+              <a:t>Finland:</a:t>
+            </a:r>
+          </a:p>
+        </p:txBody>
+      </p:sp>
+      <p:sp>
+        <p:nvSpPr>
+          <p:cNvPr id="9" name="TextBox 8"/>
+          <p:cNvSpPr txBox="1"/>
+          <p:nvPr/>
+        </p:nvSpPr>
+        <p:spPr>
+          <a:xfrm>
+            <a:off x="2743200" y="2560320"/>
+            <a:ext cx="10972800" cy="365760"/>
+          </a:xfrm>
+          <a:prstGeom prst="rect">
+            <a:avLst/>
+          </a:prstGeom>
+          <a:noFill/>
+        </p:spPr>
+        <p:txBody>
+          <a:bodyPr wrap="none">
+            <a:spAutoFit/>
+          </a:bodyPr>
+          <a:lstStyle/>
+          <a:p>
+            <a:pPr>
+              <a:defRPr sz="1300">
+                <a:solidFill>
+                  <a:srgbClr val="FFFFFF"/>
+                </a:solidFill>
+              </a:defRPr>
+            </a:pPr>
+            <a:r>
+              <a:t>Findy network + bank credentials</a:t>
+            </a:r>
+          </a:p>
+        </p:txBody>
+      </p:sp>
+      <p:sp>
+        <p:nvSpPr>
+          <p:cNvPr id="10" name="Rounded Rectangle 9"/>
           <p:cNvSpPr/>
           <p:nvPr/>
         </p:nvSpPr>
         <p:spPr>
           <a:xfrm>
-            <a:off x="3200400" y="2011680"/>
-            <a:ext cx="8046720" cy="411480"/>
+            <a:off x="457200" y="5943600"/>
+            <a:ext cx="13716000" cy="1097280"/>
           </a:xfrm>
           <a:prstGeom prst="roundRect">
             <a:avLst/>
           </a:prstGeom>
           <a:solidFill>
-            <a:srgbClr val="E8C547"/>
+            <a:srgbClr val="16213E"/>
           </a:solidFill>
           <a:ln>
             <a:solidFill>
@@ -3932,20 +4288,82 @@
           <a:bodyPr rtlCol="0" anchor="ctr"/>
           <a:lstStyle/>
           <a:p>
-            <a:pPr algn="ctr"/>
-          </a:p>
-        </p:txBody>
-      </p:sp>
-      <p:sp>
-        <p:nvSpPr>
-          <p:cNvPr id="6" name="TextBox 5"/>
+            <a:pPr algn="ctr">
+              <a:defRPr sz="1600">
+                <a:solidFill>
+                  <a:srgbClr val="FFFFFF"/>
+                </a:solidFill>
+              </a:defRPr>
+            </a:pPr>
+            <a:r>
+              <a:t>Key Insight: Most jurisdictions (67%) use a single issuer model. Multiple provider models are rare and typically found in Northern Europe with strong banking sectors.</a:t>
+            </a:r>
+          </a:p>
+        </p:txBody>
+      </p:sp>
+    </p:spTree>
+  </p:cSld>
+  <p:clrMapOvr>
+    <a:masterClrMapping/>
+  </p:clrMapOvr>
+</p:sld>
+</file>
+
+<file path=ppt/slides/slide4.xml><?xml version="1.0" encoding="utf-8"?>
+<p:sld xmlns:a="http://schemas.openxmlformats.org/drawingml/2006/main" xmlns:p="http://schemas.openxmlformats.org/presentationml/2006/main" xmlns:r="http://schemas.openxmlformats.org/officeDocument/2006/relationships">
+  <p:cSld>
+    <p:spTree>
+      <p:nvGrpSpPr>
+        <p:cNvPr id="1" name=""/>
+        <p:cNvGrpSpPr/>
+        <p:nvPr/>
+      </p:nvGrpSpPr>
+      <p:grpSpPr/>
+      <p:sp>
+        <p:nvSpPr>
+          <p:cNvPr id="2" name="TextBox 1"/>
           <p:cNvSpPr txBox="1"/>
           <p:nvPr/>
         </p:nvSpPr>
         <p:spPr>
           <a:xfrm>
-            <a:off x="11430000" y="1920240"/>
-            <a:ext cx="914400" cy="457200"/>
+            <a:off x="457200" y="365760"/>
+            <a:ext cx="13716000" cy="731520"/>
+          </a:xfrm>
+          <a:prstGeom prst="rect">
+            <a:avLst/>
+          </a:prstGeom>
+          <a:noFill/>
+        </p:spPr>
+        <p:txBody>
+          <a:bodyPr wrap="square">
+            <a:spAutoFit/>
+          </a:bodyPr>
+          <a:lstStyle/>
+          <a:p>
+            <a:pPr>
+              <a:defRPr sz="3600" b="1">
+                <a:solidFill>
+                  <a:srgbClr val="E8C547"/>
+                </a:solidFill>
+              </a:defRPr>
+            </a:pPr>
+            <a:r>
+              <a:t>Technology Approaches</a:t>
+            </a:r>
+          </a:p>
+        </p:txBody>
+      </p:sp>
+      <p:sp>
+        <p:nvSpPr>
+          <p:cNvPr id="3" name="TextBox 2"/>
+          <p:cNvSpPr txBox="1"/>
+          <p:nvPr/>
+        </p:nvSpPr>
+        <p:spPr>
+          <a:xfrm>
+            <a:off x="457200" y="1005840"/>
+            <a:ext cx="13716000" cy="457200"/>
           </a:xfrm>
           <a:prstGeom prst="rect">
             <a:avLst/>
@@ -3959,28 +4377,28 @@
           <a:lstStyle/>
           <a:p>
             <a:pPr>
-              <a:defRPr sz="1600" b="1">
-                <a:solidFill>
-                  <a:srgbClr val="FFFFFF"/>
+              <a:defRPr sz="2200">
+                <a:solidFill>
+                  <a:srgbClr val="4ADE80"/>
                 </a:solidFill>
               </a:defRPr>
             </a:pPr>
             <a:r>
-              <a:t>16</a:t>
-            </a:r>
-          </a:p>
-        </p:txBody>
-      </p:sp>
-      <p:sp>
-        <p:nvSpPr>
-          <p:cNvPr id="7" name="TextBox 6"/>
+              <a:t>Underlying Credential Formats &amp; Protocols</a:t>
+            </a:r>
+          </a:p>
+        </p:txBody>
+      </p:sp>
+      <p:sp>
+        <p:nvSpPr>
+          <p:cNvPr id="4" name="TextBox 3"/>
           <p:cNvSpPr txBox="1"/>
           <p:nvPr/>
         </p:nvSpPr>
         <p:spPr>
           <a:xfrm>
-            <a:off x="457200" y="2651760"/>
-            <a:ext cx="2743200" cy="457200"/>
+            <a:off x="457200" y="1828800"/>
+            <a:ext cx="3200400" cy="457200"/>
           </a:xfrm>
           <a:prstGeom prst="rect">
             <a:avLst/>
@@ -3994,38 +4412,38 @@
           <a:lstStyle/>
           <a:p>
             <a:pPr>
-              <a:defRPr sz="1600">
+              <a:defRPr sz="1400">
                 <a:solidFill>
                   <a:srgbClr val="FFFFFF"/>
                 </a:solidFill>
               </a:defRPr>
             </a:pPr>
             <a:r>
-              <a:t>OIDC-style auth</a:t>
-            </a:r>
-          </a:p>
-        </p:txBody>
-      </p:sp>
-      <p:sp>
-        <p:nvSpPr>
-          <p:cNvPr id="8" name="Rounded Rectangle 7"/>
+              <a:t>ISO mDL (mobile DL)</a:t>
+            </a:r>
+          </a:p>
+        </p:txBody>
+      </p:sp>
+      <p:sp>
+        <p:nvSpPr>
+          <p:cNvPr id="5" name="Rounded Rectangle 4"/>
           <p:cNvSpPr/>
           <p:nvPr/>
         </p:nvSpPr>
         <p:spPr>
           <a:xfrm>
-            <a:off x="3200400" y="2651760"/>
-            <a:ext cx="7040879" cy="411480"/>
+            <a:off x="3657600" y="1828800"/>
+            <a:ext cx="7315200" cy="365760"/>
           </a:xfrm>
           <a:prstGeom prst="roundRect">
             <a:avLst/>
           </a:prstGeom>
           <a:solidFill>
-            <a:srgbClr val="60A5FA"/>
+            <a:srgbClr val="E8C547"/>
           </a:solidFill>
           <a:ln>
             <a:solidFill>
-              <a:srgbClr val="60A5FA"/>
+              <a:srgbClr val="E8C547"/>
             </a:solidFill>
           </a:ln>
         </p:spPr>
@@ -4053,13 +4471,13 @@
       </p:sp>
       <p:sp>
         <p:nvSpPr>
-          <p:cNvPr id="9" name="TextBox 8"/>
+          <p:cNvPr id="6" name="TextBox 5"/>
           <p:cNvSpPr txBox="1"/>
           <p:nvPr/>
         </p:nvSpPr>
         <p:spPr>
           <a:xfrm>
-            <a:off x="10424159" y="2560320"/>
+            <a:off x="11155680" y="1737360"/>
             <a:ext cx="914400" cy="457200"/>
           </a:xfrm>
           <a:prstGeom prst="rect">
@@ -4074,28 +4492,28 @@
           <a:lstStyle/>
           <a:p>
             <a:pPr>
-              <a:defRPr sz="1600" b="1">
+              <a:defRPr sz="1400" b="1">
                 <a:solidFill>
                   <a:srgbClr val="FFFFFF"/>
                 </a:solidFill>
               </a:defRPr>
             </a:pPr>
             <a:r>
-              <a:t>14</a:t>
-            </a:r>
-          </a:p>
-        </p:txBody>
-      </p:sp>
-      <p:sp>
-        <p:nvSpPr>
-          <p:cNvPr id="10" name="TextBox 9"/>
+              <a:t>16</a:t>
+            </a:r>
+          </a:p>
+        </p:txBody>
+      </p:sp>
+      <p:sp>
+        <p:nvSpPr>
+          <p:cNvPr id="7" name="TextBox 6"/>
           <p:cNvSpPr txBox="1"/>
           <p:nvPr/>
         </p:nvSpPr>
         <p:spPr>
           <a:xfrm>
-            <a:off x="457200" y="3291840"/>
-            <a:ext cx="2743200" cy="457200"/>
+            <a:off x="457200" y="2331720"/>
+            <a:ext cx="3200400" cy="457200"/>
           </a:xfrm>
           <a:prstGeom prst="rect">
             <a:avLst/>
@@ -4109,38 +4527,38 @@
           <a:lstStyle/>
           <a:p>
             <a:pPr>
-              <a:defRPr sz="1600">
+              <a:defRPr sz="1400">
                 <a:solidFill>
                   <a:srgbClr val="FFFFFF"/>
                 </a:solidFill>
               </a:defRPr>
             </a:pPr>
             <a:r>
-              <a:t>EUDI Wallet</a:t>
-            </a:r>
-          </a:p>
-        </p:txBody>
-      </p:sp>
-      <p:sp>
-        <p:nvSpPr>
-          <p:cNvPr id="11" name="Rounded Rectangle 10"/>
+              <a:t>OIDC-style auth</a:t>
+            </a:r>
+          </a:p>
+        </p:txBody>
+      </p:sp>
+      <p:sp>
+        <p:nvSpPr>
+          <p:cNvPr id="8" name="Rounded Rectangle 7"/>
           <p:cNvSpPr/>
           <p:nvPr/>
         </p:nvSpPr>
         <p:spPr>
           <a:xfrm>
-            <a:off x="3200400" y="3291840"/>
-            <a:ext cx="3017520" cy="411480"/>
+            <a:off x="3657600" y="2331720"/>
+            <a:ext cx="6400800" cy="365760"/>
           </a:xfrm>
           <a:prstGeom prst="roundRect">
             <a:avLst/>
           </a:prstGeom>
           <a:solidFill>
-            <a:srgbClr val="FBBF24"/>
+            <a:srgbClr val="60A5FA"/>
           </a:solidFill>
           <a:ln>
             <a:solidFill>
-              <a:srgbClr val="FBBF24"/>
+              <a:srgbClr val="60A5FA"/>
             </a:solidFill>
           </a:ln>
         </p:spPr>
@@ -4168,13 +4586,13 @@
       </p:sp>
       <p:sp>
         <p:nvSpPr>
-          <p:cNvPr id="12" name="TextBox 11"/>
+          <p:cNvPr id="9" name="TextBox 8"/>
           <p:cNvSpPr txBox="1"/>
           <p:nvPr/>
         </p:nvSpPr>
         <p:spPr>
           <a:xfrm>
-            <a:off x="6400800" y="3200400"/>
+            <a:off x="10241280" y="2240279"/>
             <a:ext cx="914400" cy="457200"/>
           </a:xfrm>
           <a:prstGeom prst="rect">
@@ -4189,28 +4607,28 @@
           <a:lstStyle/>
           <a:p>
             <a:pPr>
-              <a:defRPr sz="1600" b="1">
+              <a:defRPr sz="1400" b="1">
                 <a:solidFill>
                   <a:srgbClr val="FFFFFF"/>
                 </a:solidFill>
               </a:defRPr>
             </a:pPr>
             <a:r>
-              <a:t>6</a:t>
-            </a:r>
-          </a:p>
-        </p:txBody>
-      </p:sp>
-      <p:sp>
-        <p:nvSpPr>
-          <p:cNvPr id="13" name="TextBox 12"/>
+              <a:t>14</a:t>
+            </a:r>
+          </a:p>
+        </p:txBody>
+      </p:sp>
+      <p:sp>
+        <p:nvSpPr>
+          <p:cNvPr id="10" name="TextBox 9"/>
           <p:cNvSpPr txBox="1"/>
           <p:nvPr/>
         </p:nvSpPr>
         <p:spPr>
           <a:xfrm>
-            <a:off x="457200" y="3931920"/>
-            <a:ext cx="2743200" cy="457200"/>
+            <a:off x="457200" y="2834639"/>
+            <a:ext cx="3200400" cy="457200"/>
           </a:xfrm>
           <a:prstGeom prst="rect">
             <a:avLst/>
@@ -4224,28 +4642,28 @@
           <a:lstStyle/>
           <a:p>
             <a:pPr>
-              <a:defRPr sz="1600">
+              <a:defRPr sz="1400">
                 <a:solidFill>
                   <a:srgbClr val="FFFFFF"/>
                 </a:solidFill>
               </a:defRPr>
             </a:pPr>
             <a:r>
-              <a:t>PKI-based</a:t>
-            </a:r>
-          </a:p>
-        </p:txBody>
-      </p:sp>
-      <p:sp>
-        <p:nvSpPr>
-          <p:cNvPr id="14" name="Rounded Rectangle 13"/>
+              <a:t>EUDI Wallet</a:t>
+            </a:r>
+          </a:p>
+        </p:txBody>
+      </p:sp>
+      <p:sp>
+        <p:nvSpPr>
+          <p:cNvPr id="11" name="Rounded Rectangle 10"/>
           <p:cNvSpPr/>
           <p:nvPr/>
         </p:nvSpPr>
         <p:spPr>
           <a:xfrm>
-            <a:off x="3200400" y="3931920"/>
-            <a:ext cx="2011680" cy="411480"/>
+            <a:off x="3657600" y="2834639"/>
+            <a:ext cx="2743200" cy="365760"/>
           </a:xfrm>
           <a:prstGeom prst="roundRect">
             <a:avLst/>
@@ -4283,13 +4701,13 @@
       </p:sp>
       <p:sp>
         <p:nvSpPr>
-          <p:cNvPr id="15" name="TextBox 14"/>
+          <p:cNvPr id="12" name="TextBox 11"/>
           <p:cNvSpPr txBox="1"/>
           <p:nvPr/>
         </p:nvSpPr>
         <p:spPr>
           <a:xfrm>
-            <a:off x="5394960" y="3840480"/>
+            <a:off x="6583680" y="2743199"/>
             <a:ext cx="914400" cy="457200"/>
           </a:xfrm>
           <a:prstGeom prst="rect">
@@ -4304,28 +4722,28 @@
           <a:lstStyle/>
           <a:p>
             <a:pPr>
-              <a:defRPr sz="1600" b="1">
+              <a:defRPr sz="1400" b="1">
                 <a:solidFill>
                   <a:srgbClr val="FFFFFF"/>
                 </a:solidFill>
               </a:defRPr>
             </a:pPr>
             <a:r>
-              <a:t>4</a:t>
-            </a:r>
-          </a:p>
-        </p:txBody>
-      </p:sp>
-      <p:sp>
-        <p:nvSpPr>
-          <p:cNvPr id="16" name="TextBox 15"/>
+              <a:t>6</a:t>
+            </a:r>
+          </a:p>
+        </p:txBody>
+      </p:sp>
+      <p:sp>
+        <p:nvSpPr>
+          <p:cNvPr id="13" name="TextBox 12"/>
           <p:cNvSpPr txBox="1"/>
           <p:nvPr/>
         </p:nvSpPr>
         <p:spPr>
           <a:xfrm>
-            <a:off x="457200" y="4572000"/>
-            <a:ext cx="2743200" cy="457200"/>
+            <a:off x="457200" y="3337559"/>
+            <a:ext cx="3200400" cy="457200"/>
           </a:xfrm>
           <a:prstGeom prst="rect">
             <a:avLst/>
@@ -4339,38 +4757,38 @@
           <a:lstStyle/>
           <a:p>
             <a:pPr>
-              <a:defRPr sz="1600">
+              <a:defRPr sz="1400">
                 <a:solidFill>
                   <a:srgbClr val="FFFFFF"/>
                 </a:solidFill>
               </a:defRPr>
             </a:pPr>
             <a:r>
-              <a:t>Verifiable Credentials</a:t>
-            </a:r>
-          </a:p>
-        </p:txBody>
-      </p:sp>
-      <p:sp>
-        <p:nvSpPr>
-          <p:cNvPr id="17" name="Rounded Rectangle 16"/>
+              <a:t>PKI-based</a:t>
+            </a:r>
+          </a:p>
+        </p:txBody>
+      </p:sp>
+      <p:sp>
+        <p:nvSpPr>
+          <p:cNvPr id="14" name="Rounded Rectangle 13"/>
           <p:cNvSpPr/>
           <p:nvPr/>
         </p:nvSpPr>
         <p:spPr>
           <a:xfrm>
-            <a:off x="3200400" y="4572000"/>
-            <a:ext cx="1508760" cy="411480"/>
+            <a:off x="3657600" y="3337559"/>
+            <a:ext cx="1828800" cy="365760"/>
           </a:xfrm>
           <a:prstGeom prst="roundRect">
             <a:avLst/>
           </a:prstGeom>
           <a:solidFill>
-            <a:srgbClr val="60A5FA"/>
+            <a:srgbClr val="FBBF24"/>
           </a:solidFill>
           <a:ln>
             <a:solidFill>
-              <a:srgbClr val="60A5FA"/>
+              <a:srgbClr val="FBBF24"/>
             </a:solidFill>
           </a:ln>
         </p:spPr>
@@ -4398,13 +4816,13 @@
       </p:sp>
       <p:sp>
         <p:nvSpPr>
-          <p:cNvPr id="18" name="TextBox 17"/>
+          <p:cNvPr id="15" name="TextBox 14"/>
           <p:cNvSpPr txBox="1"/>
           <p:nvPr/>
         </p:nvSpPr>
         <p:spPr>
           <a:xfrm>
-            <a:off x="4892040" y="4480560"/>
+            <a:off x="5669280" y="3246119"/>
             <a:ext cx="914400" cy="457200"/>
           </a:xfrm>
           <a:prstGeom prst="rect">
@@ -4419,28 +4837,28 @@
           <a:lstStyle/>
           <a:p>
             <a:pPr>
-              <a:defRPr sz="1600" b="1">
+              <a:defRPr sz="1400" b="1">
                 <a:solidFill>
                   <a:srgbClr val="FFFFFF"/>
                 </a:solidFill>
               </a:defRPr>
             </a:pPr>
             <a:r>
-              <a:t>3</a:t>
-            </a:r>
-          </a:p>
-        </p:txBody>
-      </p:sp>
-      <p:sp>
-        <p:nvSpPr>
-          <p:cNvPr id="19" name="TextBox 18"/>
+              <a:t>4</a:t>
+            </a:r>
+          </a:p>
+        </p:txBody>
+      </p:sp>
+      <p:sp>
+        <p:nvSpPr>
+          <p:cNvPr id="16" name="TextBox 15"/>
           <p:cNvSpPr txBox="1"/>
           <p:nvPr/>
         </p:nvSpPr>
         <p:spPr>
           <a:xfrm>
-            <a:off x="457200" y="5212080"/>
-            <a:ext cx="2743200" cy="457200"/>
+            <a:off x="457200" y="3840479"/>
+            <a:ext cx="3200400" cy="457200"/>
           </a:xfrm>
           <a:prstGeom prst="rect">
             <a:avLst/>
@@ -4454,28 +4872,28 @@
           <a:lstStyle/>
           <a:p>
             <a:pPr>
-              <a:defRPr sz="1600">
+              <a:defRPr sz="1400">
                 <a:solidFill>
                   <a:srgbClr val="FFFFFF"/>
                 </a:solidFill>
               </a:defRPr>
             </a:pPr>
             <a:r>
-              <a:t>PKI + Mobile ID</a:t>
-            </a:r>
-          </a:p>
-        </p:txBody>
-      </p:sp>
-      <p:sp>
-        <p:nvSpPr>
-          <p:cNvPr id="20" name="Rounded Rectangle 19"/>
+              <a:t>Verifiable Credentials</a:t>
+            </a:r>
+          </a:p>
+        </p:txBody>
+      </p:sp>
+      <p:sp>
+        <p:nvSpPr>
+          <p:cNvPr id="17" name="Rounded Rectangle 16"/>
           <p:cNvSpPr/>
           <p:nvPr/>
         </p:nvSpPr>
         <p:spPr>
           <a:xfrm>
-            <a:off x="3200400" y="5212080"/>
-            <a:ext cx="1005840" cy="411480"/>
+            <a:off x="3657600" y="3840479"/>
+            <a:ext cx="1371600" cy="365760"/>
           </a:xfrm>
           <a:prstGeom prst="roundRect">
             <a:avLst/>
@@ -4513,13 +4931,13 @@
       </p:sp>
       <p:sp>
         <p:nvSpPr>
-          <p:cNvPr id="21" name="TextBox 20"/>
+          <p:cNvPr id="18" name="TextBox 17"/>
           <p:cNvSpPr txBox="1"/>
           <p:nvPr/>
         </p:nvSpPr>
         <p:spPr>
           <a:xfrm>
-            <a:off x="4389120" y="5120640"/>
+            <a:off x="5212080" y="3749039"/>
             <a:ext cx="914400" cy="457200"/>
           </a:xfrm>
           <a:prstGeom prst="rect">
@@ -4534,28 +4952,28 @@
           <a:lstStyle/>
           <a:p>
             <a:pPr>
-              <a:defRPr sz="1600" b="1">
+              <a:defRPr sz="1400" b="1">
                 <a:solidFill>
                   <a:srgbClr val="FFFFFF"/>
                 </a:solidFill>
               </a:defRPr>
             </a:pPr>
             <a:r>
-              <a:t>2</a:t>
-            </a:r>
-          </a:p>
-        </p:txBody>
-      </p:sp>
-      <p:sp>
-        <p:nvSpPr>
-          <p:cNvPr id="22" name="TextBox 21"/>
+              <a:t>3</a:t>
+            </a:r>
+          </a:p>
+        </p:txBody>
+      </p:sp>
+      <p:sp>
+        <p:nvSpPr>
+          <p:cNvPr id="19" name="TextBox 18"/>
           <p:cNvSpPr txBox="1"/>
           <p:nvPr/>
         </p:nvSpPr>
         <p:spPr>
           <a:xfrm>
-            <a:off x="457200" y="5852160"/>
-            <a:ext cx="2743200" cy="457200"/>
+            <a:off x="457200" y="4343399"/>
+            <a:ext cx="3200400" cy="457200"/>
           </a:xfrm>
           <a:prstGeom prst="rect">
             <a:avLst/>
@@ -4569,28 +4987,28 @@
           <a:lstStyle/>
           <a:p>
             <a:pPr>
-              <a:defRPr sz="1600">
+              <a:defRPr sz="1400">
                 <a:solidFill>
                   <a:srgbClr val="FFFFFF"/>
                 </a:solidFill>
               </a:defRPr>
             </a:pPr>
             <a:r>
-              <a:t>Biometric Database</a:t>
-            </a:r>
-          </a:p>
-        </p:txBody>
-      </p:sp>
-      <p:sp>
-        <p:nvSpPr>
-          <p:cNvPr id="23" name="Rounded Rectangle 22"/>
+              <a:t>PKI + Mobile ID</a:t>
+            </a:r>
+          </a:p>
+        </p:txBody>
+      </p:sp>
+      <p:sp>
+        <p:nvSpPr>
+          <p:cNvPr id="20" name="Rounded Rectangle 19"/>
           <p:cNvSpPr/>
           <p:nvPr/>
         </p:nvSpPr>
         <p:spPr>
           <a:xfrm>
-            <a:off x="3200400" y="5852160"/>
-            <a:ext cx="1005840" cy="411480"/>
+            <a:off x="3657600" y="4343399"/>
+            <a:ext cx="914400" cy="365760"/>
           </a:xfrm>
           <a:prstGeom prst="roundRect">
             <a:avLst/>
@@ -4628,13 +5046,13 @@
       </p:sp>
       <p:sp>
         <p:nvSpPr>
-          <p:cNvPr id="24" name="TextBox 23"/>
+          <p:cNvPr id="21" name="TextBox 20"/>
           <p:cNvSpPr txBox="1"/>
           <p:nvPr/>
         </p:nvSpPr>
         <p:spPr>
           <a:xfrm>
-            <a:off x="4389120" y="5760720"/>
+            <a:off x="4754880" y="4251959"/>
             <a:ext cx="914400" cy="457200"/>
           </a:xfrm>
           <a:prstGeom prst="rect">
@@ -4649,7 +5067,7 @@
           <a:lstStyle/>
           <a:p>
             <a:pPr>
-              <a:defRPr sz="1600" b="1">
+              <a:defRPr sz="1400" b="1">
                 <a:solidFill>
                   <a:srgbClr val="FFFFFF"/>
                 </a:solidFill>
@@ -4663,24 +5081,59 @@
       </p:sp>
       <p:sp>
         <p:nvSpPr>
-          <p:cNvPr id="25" name="Rounded Rectangle 24"/>
+          <p:cNvPr id="22" name="TextBox 21"/>
+          <p:cNvSpPr txBox="1"/>
+          <p:nvPr/>
+        </p:nvSpPr>
+        <p:spPr>
+          <a:xfrm>
+            <a:off x="457200" y="4846319"/>
+            <a:ext cx="3200400" cy="457200"/>
+          </a:xfrm>
+          <a:prstGeom prst="rect">
+            <a:avLst/>
+          </a:prstGeom>
+          <a:noFill/>
+        </p:spPr>
+        <p:txBody>
+          <a:bodyPr wrap="none">
+            <a:spAutoFit/>
+          </a:bodyPr>
+          <a:lstStyle/>
+          <a:p>
+            <a:pPr>
+              <a:defRPr sz="1400">
+                <a:solidFill>
+                  <a:srgbClr val="FFFFFF"/>
+                </a:solidFill>
+              </a:defRPr>
+            </a:pPr>
+            <a:r>
+              <a:t>Biometric Database</a:t>
+            </a:r>
+          </a:p>
+        </p:txBody>
+      </p:sp>
+      <p:sp>
+        <p:nvSpPr>
+          <p:cNvPr id="23" name="Rounded Rectangle 22"/>
           <p:cNvSpPr/>
           <p:nvPr/>
         </p:nvSpPr>
         <p:spPr>
           <a:xfrm>
-            <a:off x="457200" y="6400800"/>
-            <a:ext cx="13716000" cy="1097280"/>
+            <a:off x="3657600" y="4846319"/>
+            <a:ext cx="914400" cy="365760"/>
           </a:xfrm>
           <a:prstGeom prst="roundRect">
             <a:avLst/>
           </a:prstGeom>
           <a:solidFill>
-            <a:srgbClr val="16213E"/>
+            <a:srgbClr val="60A5FA"/>
           </a:solidFill>
           <a:ln>
             <a:solidFill>
-              <a:srgbClr val="E8C547"/>
+              <a:srgbClr val="60A5FA"/>
             </a:solidFill>
           </a:ln>
         </p:spPr>
@@ -4702,15 +5155,95 @@
           <a:bodyPr rtlCol="0" anchor="ctr"/>
           <a:lstStyle/>
           <a:p>
+            <a:pPr algn="ctr"/>
+          </a:p>
+        </p:txBody>
+      </p:sp>
+      <p:sp>
+        <p:nvSpPr>
+          <p:cNvPr id="24" name="TextBox 23"/>
+          <p:cNvSpPr txBox="1"/>
+          <p:nvPr/>
+        </p:nvSpPr>
+        <p:spPr>
+          <a:xfrm>
+            <a:off x="4754880" y="4754879"/>
+            <a:ext cx="914400" cy="457200"/>
+          </a:xfrm>
+          <a:prstGeom prst="rect">
+            <a:avLst/>
+          </a:prstGeom>
+          <a:noFill/>
+        </p:spPr>
+        <p:txBody>
+          <a:bodyPr wrap="none">
+            <a:spAutoFit/>
+          </a:bodyPr>
+          <a:lstStyle/>
+          <a:p>
+            <a:pPr>
+              <a:defRPr sz="1400" b="1">
+                <a:solidFill>
+                  <a:srgbClr val="FFFFFF"/>
+                </a:solidFill>
+              </a:defRPr>
+            </a:pPr>
+            <a:r>
+              <a:t>2</a:t>
+            </a:r>
+          </a:p>
+        </p:txBody>
+      </p:sp>
+      <p:sp>
+        <p:nvSpPr>
+          <p:cNvPr id="25" name="Rounded Rectangle 24"/>
+          <p:cNvSpPr/>
+          <p:nvPr/>
+        </p:nvSpPr>
+        <p:spPr>
+          <a:xfrm>
+            <a:off x="457200" y="6217920"/>
+            <a:ext cx="13716000" cy="1097280"/>
+          </a:xfrm>
+          <a:prstGeom prst="roundRect">
+            <a:avLst/>
+          </a:prstGeom>
+          <a:solidFill>
+            <a:srgbClr val="16213E"/>
+          </a:solidFill>
+          <a:ln>
+            <a:solidFill>
+              <a:srgbClr val="E8C547"/>
+            </a:solidFill>
+          </a:ln>
+        </p:spPr>
+        <p:style>
+          <a:lnRef idx="1">
+            <a:schemeClr val="accent1"/>
+          </a:lnRef>
+          <a:fillRef idx="3">
+            <a:schemeClr val="accent1"/>
+          </a:fillRef>
+          <a:effectRef idx="2">
+            <a:schemeClr val="accent1"/>
+          </a:effectRef>
+          <a:fontRef idx="minor">
+            <a:schemeClr val="lt1"/>
+          </a:fontRef>
+        </p:style>
+        <p:txBody>
+          <a:bodyPr rtlCol="0" anchor="ctr"/>
+          <a:lstStyle/>
+          <a:p>
             <a:pPr algn="ctr">
-              <a:defRPr sz="1600">
+              <a:defRPr sz="1400">
                 <a:solidFill>
                   <a:srgbClr val="FFFFFF"/>
                 </a:solidFill>
               </a:defRPr>
             </a:pPr>
             <a:r>
-              <a:t>Emerging Trend: ISO 18013-5 (mobile Driver License) is the most common format, especially in the US. EUDI Wallet adoption is accelerating in Europe with 2026 deadline.</a:t>
+              <a:t>Emerging Trend: ISO 18013-5 (mobile Driver License) is the most common format in the US. EUDI Wallet adoption accelerating in Europe with 2026 deadline.</a:t>
             </a:r>
           </a:p>
         </p:txBody>

</xml_diff>